<commit_message>
Random-seed baseline: final unlzma/bunzip2 results, roll into OVERALL_RESULTS
unlzma: no crash in ~16.3h (4.5M execs) despite reaching the identical
83.50% coverage ceiling as the blind campaign -- a target-value
search-efficiency gap, not a reachability gap (blind found it in ~80
min from the same plateau).

bunzip2's format-valid-random condition: no crash in ~15.7h (~4M
execs) despite reaching 84.62% coverage, essentially matching blind's
85.31%. All 3 strategies (blind, pure random, format-valid random) now
agree the trigger is unreachable by any undirected search, reinforcing
the structural-infeasibility finding from a third angle.

Folded the full 4-case random-baseline comparison into
OVERALL_RESULTS.md's per-CVE pipeline table (previously only reflected
blind-campaign results) and updated the awk campaign's live crash
count (30 crashes / 9 hangs, ~51.6h as of today, all triaged).

Co-Authored-By: Claude Sonnet 5 <noreply@anthropic.com>
</commit_message>
<xml_diff>
--- a/presentations/W3_progress.pptx
+++ b/presentations/W3_progress.pptx
@@ -6508,7 +6508,18 @@
                             <a:srgbClr val="222222"/>
                           </a:solidFill>
                         </a:rPr>
-                        <a:t>Running now</a:t>
+                        <a:t>No crash in ~16.3h</a:t>
+                      </a:r>
+                    </a:p>
+                    <a:p>
+                      <a:pPr algn="l"/>
+                      <a:r>
+                        <a:rPr sz="950" b="0">
+                          <a:solidFill>
+                            <a:srgbClr val="222222"/>
+                          </a:solidFill>
+                        </a:rPr>
+                        <a:t>(4,538,490 execs, 83.50% cov.)</a:t>
                       </a:r>
                     </a:p>
                   </a:txBody>
@@ -6530,7 +6541,7 @@
                             <a:srgbClr val="222222"/>
                           </a:solidFill>
                         </a:rPr>
-                        <a:t>Blind confirmed (82 min); random baseline in progress</a:t>
+                        <a:t>Same coverage ceiling as blind (83.50% both) -- not a reachability gap, a target-value search-efficiency gap: blind found it in ~80 min, random didn't in ~16.3h (~12x longer, ~26x more execs)</a:t>
                       </a:r>
                     </a:p>
                   </a:txBody>
@@ -6642,7 +6653,7 @@
                             <a:srgbClr val="222222"/>
                           </a:solidFill>
                         </a:rPr>
-                        <a:t>Random never passed the format's magic-byte header (corpus stuck at 3 seeds, 45 cycles, 0 new edges). Added a 3rd condition to isolate why: real-bzip2-compressed random content (mechanical, no LLM) -- just 3 such seeds already reach 56.64% coverage (81/143 edges) before any mutation, confirming it was a gate-passing failure, not a hard-interior problem. Campaign in progress.</a:t>
+                        <a:t>Random never passed the format's magic-byte header. Added a 3rd condition (real-bzip2-compressed random content, mechanical, no LLM): reached 84.62% coverage (121/143 edges, ~15.7h, ~4M execs) -- essentially the same ceiling as blind -- and STILL found 0 crashes. All 3 strategies agree: not an unexplored path, a specific value combination undirected mutation of any kind doesn't produce</a:t>
                       </a:r>
                     </a:p>
                   </a:txBody>
@@ -6788,7 +6799,7 @@
                 </a:solidFill>
                 <a:latin typeface="Calibri"/>
               </a:rPr>
-              <a:t>Mixed result, reported plainly: blind seeding gave a large head start on man, random matched/beat it on udhcpc6, and on bunzip2 blind was the only strategy that could even pass the format's magic-byte gate. 2 of 5 comparisons still to run/finish.</a:t>
+              <a:t>Mixed result, reported plainly: blind wins on man and unlzma, random wins on udhcpc6, and on bunzip2 all 3 strategies agree the target is unreachable by any undirected search. 4 of 5 comparisons complete; awk still running.</a:t>
             </a:r>
           </a:p>
         </p:txBody>
@@ -7298,7 +7309,7 @@
                             <a:srgbClr val="222222"/>
                           </a:solidFill>
                         </a:rPr>
-                        <a:t>Neither strategy found a crash: blind</a:t>
+                        <a:t>All 3 strategies agree: blind, random,</a:t>
                       </a:r>
                     </a:p>
                     <a:p>
@@ -7309,7 +7320,7 @@
                             <a:srgbClr val="222222"/>
                           </a:solidFill>
                         </a:rPr>
-                        <a:t>(2.3h) searched inside the format and</a:t>
+                        <a:t>and format-valid-random (84.62% cov.,</a:t>
                       </a:r>
                     </a:p>
                     <a:p>
@@ -7320,7 +7331,7 @@
                             <a:srgbClr val="222222"/>
                           </a:solidFill>
                         </a:rPr>
-                        <a:t>found nothing; random (19min) never</a:t>
+                        <a:t>~15.7h) all found 0 crashes -- not an</a:t>
                       </a:r>
                     </a:p>
                     <a:p>
@@ -7331,7 +7342,7 @@
                             <a:srgbClr val="222222"/>
                           </a:solidFill>
                         </a:rPr>
-                        <a:t>passed the magic-byte header at all</a:t>
+                        <a:t>unexplored path, an unreachable value</a:t>
                       </a:r>
                     </a:p>
                   </a:txBody>
@@ -7599,7 +7610,18 @@
                             <a:srgbClr val="222222"/>
                           </a:solidFill>
                         </a:rPr>
-                        <a:t>baseline running now</a:t>
+                        <a:t>found 0 crashes in 16.3h despite same</a:t>
+                      </a:r>
+                    </a:p>
+                    <a:p>
+                      <a:pPr algn="l"/>
+                      <a:r>
+                        <a:rPr sz="950" b="0">
+                          <a:solidFill>
+                            <a:srgbClr val="222222"/>
+                          </a:solidFill>
+                        </a:rPr>
+                        <a:t>coverage ceiling (83.50% both)</a:t>
                       </a:r>
                     </a:p>
                   </a:txBody>

</xml_diff>